<commit_message>
chore(preview): secteur_Energy_S&P_500 outputs regeneres
</commit_message>
<xml_diff>
--- a/preview/secteur_Energy_S&P_500/secteur_Energy_S&P_500.pptx
+++ b/preview/secteur_Energy_S&P_500/secteur_Energy_S&P_500.pptx
@@ -21882,7 +21882,7 @@
         <p:spPr>
           <a:xfrm>
             <a:off x="324000" y="827999"/>
-            <a:ext cx="5400000" cy="3671999"/>
+            <a:ext cx="5940000" cy="3671999"/>
           </a:xfrm>
           <a:prstGeom prst="rect">
             <a:avLst/>
@@ -21897,8 +21897,8 @@
         </p:nvSpPr>
         <p:spPr>
           <a:xfrm>
-            <a:off x="5903999" y="827999"/>
-            <a:ext cx="2916000" cy="3671999"/>
+            <a:off x="6336000" y="827999"/>
+            <a:ext cx="2448000" cy="3671999"/>
           </a:xfrm>
           <a:prstGeom prst="rect">
             <a:avLst/>
@@ -21940,8 +21940,8 @@
         </p:nvSpPr>
         <p:spPr>
           <a:xfrm>
-            <a:off x="5903999" y="827999"/>
-            <a:ext cx="2916000" cy="234000"/>
+            <a:off x="6336000" y="827999"/>
+            <a:ext cx="2448000" cy="234000"/>
           </a:xfrm>
           <a:prstGeom prst="rect">
             <a:avLst/>
@@ -21983,8 +21983,8 @@
         </p:nvSpPr>
         <p:spPr>
           <a:xfrm>
-            <a:off x="5976000" y="846000"/>
-            <a:ext cx="2808000" cy="198000"/>
+            <a:off x="6408000" y="846000"/>
+            <a:ext cx="2340000" cy="198000"/>
           </a:xfrm>
           <a:prstGeom prst="rect">
             <a:avLst/>
@@ -22004,64 +22004,21 @@
                   <a:srgbClr val="FFFFFF"/>
                 </a:solidFill>
               </a:rPr>
-              <a:t>LEGENDE — SOCIETES</a:t>
-            </a:r>
-          </a:p>
-        </p:txBody>
-      </p:sp>
-      <p:sp>
-        <p:nvSpPr>
-          <p:cNvPr id="19" name="Rectangle 18"/>
-          <p:cNvSpPr/>
-          <p:nvPr/>
-        </p:nvSpPr>
-        <p:spPr>
-          <a:xfrm>
-            <a:off x="5940000" y="1177200"/>
-            <a:ext cx="180000" cy="108000"/>
-          </a:xfrm>
-          <a:prstGeom prst="rect">
-            <a:avLst/>
-          </a:prstGeom>
-          <a:solidFill>
-            <a:srgbClr val="1B3A6B"/>
-          </a:solidFill>
-          <a:ln>
-            <a:noFill/>
-          </a:ln>
-        </p:spPr>
-        <p:style>
-          <a:lnRef idx="1">
-            <a:schemeClr val="accent1"/>
-          </a:lnRef>
-          <a:fillRef idx="3">
-            <a:schemeClr val="accent1"/>
-          </a:fillRef>
-          <a:effectRef idx="2">
-            <a:schemeClr val="accent1"/>
-          </a:effectRef>
-          <a:fontRef idx="minor">
-            <a:schemeClr val="lt1"/>
-          </a:fontRef>
-        </p:style>
-        <p:txBody>
-          <a:bodyPr rtlCol="0" anchor="ctr"/>
-          <a:lstStyle/>
-          <a:p>
-            <a:pPr algn="ctr"/>
-          </a:p>
-        </p:txBody>
-      </p:sp>
-      <p:sp>
-        <p:nvSpPr>
-          <p:cNvPr id="20" name="TextBox 19"/>
+              <a:t>LECTURE ANALYTIQUE</a:t>
+            </a:r>
+          </a:p>
+        </p:txBody>
+      </p:sp>
+      <p:sp>
+        <p:nvSpPr>
+          <p:cNvPr id="19" name="TextBox 18"/>
           <p:cNvSpPr txBox="1"/>
           <p:nvPr/>
         </p:nvSpPr>
         <p:spPr>
           <a:xfrm>
-            <a:off x="6192000" y="1134000"/>
-            <a:ext cx="2556000" cy="216000"/>
+            <a:off x="6408000" y="1152000"/>
+            <a:ext cx="2304000" cy="324000"/>
           </a:xfrm>
           <a:prstGeom prst="rect">
             <a:avLst/>
@@ -22076,26 +22033,26 @@
           <a:p>
             <a:pPr algn="l"/>
             <a:r>
-              <a:rPr sz="900" b="1" i="0">
+              <a:rPr sz="700" b="1" i="0">
                 <a:solidFill>
                   <a:srgbClr val="1B3A6B"/>
                 </a:solidFill>
               </a:rPr>
-              <a:t>XOM  —  Exxon Mobil Corporation</a:t>
-            </a:r>
-          </a:p>
-        </p:txBody>
-      </p:sp>
-      <p:sp>
-        <p:nvSpPr>
-          <p:cNvPr id="21" name="TextBox 20"/>
+              <a:t>MEILLEURE PERFORMANCE</a:t>
+            </a:r>
+          </a:p>
+        </p:txBody>
+      </p:sp>
+      <p:sp>
+        <p:nvSpPr>
+          <p:cNvPr id="20" name="TextBox 19"/>
           <p:cNvSpPr txBox="1"/>
           <p:nvPr/>
         </p:nvSpPr>
         <p:spPr>
           <a:xfrm>
-            <a:off x="6192000" y="1357200"/>
-            <a:ext cx="2556000" cy="180000"/>
+            <a:off x="6408000" y="1314000"/>
+            <a:ext cx="2304000" cy="324000"/>
           </a:xfrm>
           <a:prstGeom prst="rect">
             <a:avLst/>
@@ -22110,69 +22067,26 @@
           <a:p>
             <a:pPr algn="l"/>
             <a:r>
-              <a:rPr sz="800" b="0" i="0">
-                <a:solidFill>
-                  <a:srgbClr val="555555"/>
+              <a:rPr sz="900" b="1" i="0">
+                <a:solidFill>
+                  <a:srgbClr val="1B3A6B"/>
                 </a:solidFill>
               </a:rPr>
-              <a:t>Score 58/100  ·  HOLD</a:t>
-            </a:r>
-          </a:p>
-        </p:txBody>
-      </p:sp>
-      <p:sp>
-        <p:nvSpPr>
-          <p:cNvPr id="22" name="Rectangle 21"/>
-          <p:cNvSpPr/>
-          <p:nvPr/>
-        </p:nvSpPr>
-        <p:spPr>
-          <a:xfrm>
-            <a:off x="5940000" y="1507950"/>
-            <a:ext cx="180000" cy="108000"/>
-          </a:xfrm>
-          <a:prstGeom prst="rect">
-            <a:avLst/>
-          </a:prstGeom>
-          <a:solidFill>
-            <a:srgbClr val="1A7A4A"/>
-          </a:solidFill>
-          <a:ln>
-            <a:noFill/>
-          </a:ln>
-        </p:spPr>
-        <p:style>
-          <a:lnRef idx="1">
-            <a:schemeClr val="accent1"/>
-          </a:lnRef>
-          <a:fillRef idx="3">
-            <a:schemeClr val="accent1"/>
-          </a:fillRef>
-          <a:effectRef idx="2">
-            <a:schemeClr val="accent1"/>
-          </a:effectRef>
-          <a:fontRef idx="minor">
-            <a:schemeClr val="lt1"/>
-          </a:fontRef>
-        </p:style>
-        <p:txBody>
-          <a:bodyPr rtlCol="0" anchor="ctr"/>
-          <a:lstStyle/>
-          <a:p>
-            <a:pPr algn="ctr"/>
-          </a:p>
-        </p:txBody>
-      </p:sp>
-      <p:sp>
-        <p:nvSpPr>
-          <p:cNvPr id="23" name="TextBox 22"/>
+              <a:t>VLO  +82%  sur 52 semaines</a:t>
+            </a:r>
+          </a:p>
+        </p:txBody>
+      </p:sp>
+      <p:sp>
+        <p:nvSpPr>
+          <p:cNvPr id="21" name="TextBox 20"/>
           <p:cNvSpPr txBox="1"/>
           <p:nvPr/>
         </p:nvSpPr>
         <p:spPr>
           <a:xfrm>
-            <a:off x="6192000" y="1464749"/>
-            <a:ext cx="2556000" cy="216000"/>
+            <a:off x="6408000" y="1655999"/>
+            <a:ext cx="2304000" cy="324000"/>
           </a:xfrm>
           <a:prstGeom prst="rect">
             <a:avLst/>
@@ -22187,26 +22101,26 @@
           <a:p>
             <a:pPr algn="l"/>
             <a:r>
-              <a:rPr sz="900" b="1" i="0">
+              <a:rPr sz="700" b="1" i="0">
                 <a:solidFill>
                   <a:srgbClr val="1B3A6B"/>
                 </a:solidFill>
               </a:rPr>
-              <a:t>CVX  —  Chevron Corporation</a:t>
-            </a:r>
-          </a:p>
-        </p:txBody>
-      </p:sp>
-      <p:sp>
-        <p:nvSpPr>
-          <p:cNvPr id="24" name="TextBox 23"/>
+              <a:t>PIRE PERFORMANCE</a:t>
+            </a:r>
+          </a:p>
+        </p:txBody>
+      </p:sp>
+      <p:sp>
+        <p:nvSpPr>
+          <p:cNvPr id="22" name="TextBox 21"/>
           <p:cNvSpPr txBox="1"/>
           <p:nvPr/>
         </p:nvSpPr>
         <p:spPr>
           <a:xfrm>
-            <a:off x="6192000" y="1687950"/>
-            <a:ext cx="2556000" cy="180000"/>
+            <a:off x="6408000" y="1818000"/>
+            <a:ext cx="2304000" cy="324000"/>
           </a:xfrm>
           <a:prstGeom prst="rect">
             <a:avLst/>
@@ -22221,69 +22135,26 @@
           <a:p>
             <a:pPr algn="l"/>
             <a:r>
-              <a:rPr sz="800" b="0" i="0">
-                <a:solidFill>
-                  <a:srgbClr val="555555"/>
+              <a:rPr sz="900" b="1" i="0">
+                <a:solidFill>
+                  <a:srgbClr val="A82020"/>
                 </a:solidFill>
               </a:rPr>
-              <a:t>Score 44/100  ·  SELL</a:t>
-            </a:r>
-          </a:p>
-        </p:txBody>
-      </p:sp>
-      <p:sp>
-        <p:nvSpPr>
-          <p:cNvPr id="25" name="Rectangle 24"/>
-          <p:cNvSpPr/>
-          <p:nvPr/>
-        </p:nvSpPr>
-        <p:spPr>
-          <a:xfrm>
-            <a:off x="5940000" y="1838700"/>
-            <a:ext cx="180000" cy="108000"/>
-          </a:xfrm>
-          <a:prstGeom prst="rect">
-            <a:avLst/>
-          </a:prstGeom>
-          <a:solidFill>
-            <a:srgbClr val="A82020"/>
-          </a:solidFill>
-          <a:ln>
-            <a:noFill/>
-          </a:ln>
-        </p:spPr>
-        <p:style>
-          <a:lnRef idx="1">
-            <a:schemeClr val="accent1"/>
-          </a:lnRef>
-          <a:fillRef idx="3">
-            <a:schemeClr val="accent1"/>
-          </a:fillRef>
-          <a:effectRef idx="2">
-            <a:schemeClr val="accent1"/>
-          </a:effectRef>
-          <a:fontRef idx="minor">
-            <a:schemeClr val="lt1"/>
-          </a:fontRef>
-        </p:style>
-        <p:txBody>
-          <a:bodyPr rtlCol="0" anchor="ctr"/>
-          <a:lstStyle/>
-          <a:p>
-            <a:pPr algn="ctr"/>
-          </a:p>
-        </p:txBody>
-      </p:sp>
-      <p:sp>
-        <p:nvSpPr>
-          <p:cNvPr id="26" name="TextBox 25"/>
+              <a:t>EOG  +8%  sur 52 semaines</a:t>
+            </a:r>
+          </a:p>
+        </p:txBody>
+      </p:sp>
+      <p:sp>
+        <p:nvSpPr>
+          <p:cNvPr id="23" name="TextBox 22"/>
           <p:cNvSpPr txBox="1"/>
           <p:nvPr/>
         </p:nvSpPr>
         <p:spPr>
           <a:xfrm>
-            <a:off x="6192000" y="1795500"/>
-            <a:ext cx="2556000" cy="216000"/>
+            <a:off x="6408000" y="2196000"/>
+            <a:ext cx="2304000" cy="324000"/>
           </a:xfrm>
           <a:prstGeom prst="rect">
             <a:avLst/>
@@ -22298,26 +22169,26 @@
           <a:p>
             <a:pPr algn="l"/>
             <a:r>
-              <a:rPr sz="900" b="1" i="0">
+              <a:rPr sz="700" b="1" i="0">
                 <a:solidFill>
                   <a:srgbClr val="1B3A6B"/>
                 </a:solidFill>
               </a:rPr>
-              <a:t>COP  —  ConocoPhillips</a:t>
-            </a:r>
-          </a:p>
-        </p:txBody>
-      </p:sp>
-      <p:sp>
-        <p:nvSpPr>
-          <p:cNvPr id="27" name="TextBox 26"/>
+              <a:t>DISPERSION</a:t>
+            </a:r>
+          </a:p>
+        </p:txBody>
+      </p:sp>
+      <p:sp>
+        <p:nvSpPr>
+          <p:cNvPr id="24" name="TextBox 23"/>
           <p:cNvSpPr txBox="1"/>
           <p:nvPr/>
         </p:nvSpPr>
         <p:spPr>
           <a:xfrm>
-            <a:off x="6192000" y="2018700"/>
-            <a:ext cx="2556000" cy="180000"/>
+            <a:off x="6408000" y="2358000"/>
+            <a:ext cx="2304000" cy="324000"/>
           </a:xfrm>
           <a:prstGeom prst="rect">
             <a:avLst/>
@@ -22337,64 +22208,21 @@
                   <a:srgbClr val="555555"/>
                 </a:solidFill>
               </a:rPr>
-              <a:t>Score 56/100  ·  HOLD</a:t>
-            </a:r>
-          </a:p>
-        </p:txBody>
-      </p:sp>
-      <p:sp>
-        <p:nvSpPr>
-          <p:cNvPr id="28" name="Rectangle 27"/>
-          <p:cNvSpPr/>
-          <p:nvPr/>
-        </p:nvSpPr>
-        <p:spPr>
-          <a:xfrm>
-            <a:off x="5940000" y="2169450"/>
-            <a:ext cx="180000" cy="108000"/>
-          </a:xfrm>
-          <a:prstGeom prst="rect">
-            <a:avLst/>
-          </a:prstGeom>
-          <a:solidFill>
-            <a:srgbClr val="B06000"/>
-          </a:solidFill>
-          <a:ln>
-            <a:noFill/>
-          </a:ln>
-        </p:spPr>
-        <p:style>
-          <a:lnRef idx="1">
-            <a:schemeClr val="accent1"/>
-          </a:lnRef>
-          <a:fillRef idx="3">
-            <a:schemeClr val="accent1"/>
-          </a:fillRef>
-          <a:effectRef idx="2">
-            <a:schemeClr val="accent1"/>
-          </a:effectRef>
-          <a:fontRef idx="minor">
-            <a:schemeClr val="lt1"/>
-          </a:fontRef>
-        </p:style>
-        <p:txBody>
-          <a:bodyPr rtlCol="0" anchor="ctr"/>
-          <a:lstStyle/>
-          <a:p>
-            <a:pPr algn="ctr"/>
-          </a:p>
-        </p:txBody>
-      </p:sp>
-      <p:sp>
-        <p:nvSpPr>
-          <p:cNvPr id="29" name="TextBox 28"/>
+              <a:t>Ecart 74 pts — 8 valeur(s) positives vs 0 negatives.</a:t>
+            </a:r>
+          </a:p>
+        </p:txBody>
+      </p:sp>
+      <p:sp>
+        <p:nvSpPr>
+          <p:cNvPr id="25" name="TextBox 24"/>
           <p:cNvSpPr txBox="1"/>
           <p:nvPr/>
         </p:nvSpPr>
         <p:spPr>
           <a:xfrm>
-            <a:off x="6192000" y="2126250"/>
-            <a:ext cx="2556000" cy="216000"/>
+            <a:off x="6408000" y="2772000"/>
+            <a:ext cx="2304000" cy="324000"/>
           </a:xfrm>
           <a:prstGeom prst="rect">
             <a:avLst/>
@@ -22409,26 +22237,26 @@
           <a:p>
             <a:pPr algn="l"/>
             <a:r>
-              <a:rPr sz="900" b="1" i="0">
+              <a:rPr sz="700" b="1" i="0">
                 <a:solidFill>
                   <a:srgbClr val="1B3A6B"/>
                 </a:solidFill>
               </a:rPr>
-              <a:t>EOG  —  EOG Resources, Inc.</a:t>
-            </a:r>
-          </a:p>
-        </p:txBody>
-      </p:sp>
-      <p:sp>
-        <p:nvSpPr>
-          <p:cNvPr id="30" name="TextBox 29"/>
+              <a:t>INTERPRETATION</a:t>
+            </a:r>
+          </a:p>
+        </p:txBody>
+      </p:sp>
+      <p:sp>
+        <p:nvSpPr>
+          <p:cNvPr id="26" name="TextBox 25"/>
           <p:cNvSpPr txBox="1"/>
           <p:nvPr/>
         </p:nvSpPr>
         <p:spPr>
           <a:xfrm>
-            <a:off x="6192000" y="2349450"/>
-            <a:ext cx="2556000" cy="180000"/>
+            <a:off x="6408000" y="2934000"/>
+            <a:ext cx="2304000" cy="324000"/>
           </a:xfrm>
           <a:prstGeom prst="rect">
             <a:avLst/>
@@ -22443,69 +22271,26 @@
           <a:p>
             <a:pPr algn="l"/>
             <a:r>
-              <a:rPr sz="800" b="0" i="0">
+              <a:rPr sz="750" b="0" i="0">
                 <a:solidFill>
                   <a:srgbClr val="555555"/>
                 </a:solidFill>
               </a:rPr>
-              <a:t>Score 67/100  ·  HOLD</a:t>
-            </a:r>
-          </a:p>
-        </p:txBody>
-      </p:sp>
-      <p:sp>
-        <p:nvSpPr>
-          <p:cNvPr id="31" name="Rectangle 30"/>
-          <p:cNvSpPr/>
-          <p:nvPr/>
-        </p:nvSpPr>
-        <p:spPr>
-          <a:xfrm>
-            <a:off x="5940000" y="2500200"/>
-            <a:ext cx="180000" cy="108000"/>
-          </a:xfrm>
-          <a:prstGeom prst="rect">
-            <a:avLst/>
-          </a:prstGeom>
-          <a:solidFill>
-            <a:srgbClr val="2A5298"/>
-          </a:solidFill>
-          <a:ln>
-            <a:noFill/>
-          </a:ln>
-        </p:spPr>
-        <p:style>
-          <a:lnRef idx="1">
-            <a:schemeClr val="accent1"/>
-          </a:lnRef>
-          <a:fillRef idx="3">
-            <a:schemeClr val="accent1"/>
-          </a:fillRef>
-          <a:effectRef idx="2">
-            <a:schemeClr val="accent1"/>
-          </a:effectRef>
-          <a:fontRef idx="minor">
-            <a:schemeClr val="lt1"/>
-          </a:fontRef>
-        </p:style>
-        <p:txBody>
-          <a:bodyPr rtlCol="0" anchor="ctr"/>
-          <a:lstStyle/>
-          <a:p>
-            <a:pPr algn="ctr"/>
-          </a:p>
-        </p:txBody>
-      </p:sp>
-      <p:sp>
-        <p:nvSpPr>
-          <p:cNvPr id="32" name="TextBox 31"/>
+              <a:t>La dispersion des trajectoires reflète la bifurcation sectorielle : certains acteurs captent l'essentiel de la creation de valeur tandis que d'autres subissent des sorties de capitaux structurelles.</a:t>
+            </a:r>
+          </a:p>
+        </p:txBody>
+      </p:sp>
+      <p:sp>
+        <p:nvSpPr>
+          <p:cNvPr id="27" name="TextBox 26"/>
           <p:cNvSpPr txBox="1"/>
           <p:nvPr/>
         </p:nvSpPr>
         <p:spPr>
           <a:xfrm>
-            <a:off x="6192000" y="2456999"/>
-            <a:ext cx="2556000" cy="216000"/>
+            <a:off x="6408000" y="3366000"/>
+            <a:ext cx="2304000" cy="324000"/>
           </a:xfrm>
           <a:prstGeom prst="rect">
             <a:avLst/>
@@ -22520,497 +22305,19 @@
           <a:p>
             <a:pPr algn="l"/>
             <a:r>
-              <a:rPr sz="900" b="1" i="0">
-                <a:solidFill>
-                  <a:srgbClr val="1B3A6B"/>
+              <a:rPr sz="750" b="0" i="0">
+                <a:solidFill>
+                  <a:srgbClr val="555555"/>
                 </a:solidFill>
               </a:rPr>
-              <a:t>SLB  —  SLB N.V.</a:t>
-            </a:r>
-          </a:p>
-        </p:txBody>
-      </p:sp>
-      <p:sp>
-        <p:nvSpPr>
-          <p:cNvPr id="33" name="TextBox 32"/>
-          <p:cNvSpPr txBox="1"/>
-          <p:nvPr/>
-        </p:nvSpPr>
-        <p:spPr>
-          <a:xfrm>
-            <a:off x="6192000" y="2680200"/>
-            <a:ext cx="2556000" cy="180000"/>
-          </a:xfrm>
-          <a:prstGeom prst="rect">
-            <a:avLst/>
-          </a:prstGeom>
-          <a:noFill/>
-        </p:spPr>
-        <p:txBody>
-          <a:bodyPr wrap="square">
-            <a:spAutoFit/>
-          </a:bodyPr>
-          <a:lstStyle/>
-          <a:p>
-            <a:pPr algn="l"/>
-            <a:r>
-              <a:rPr sz="800" b="0" i="0">
-                <a:solidFill>
-                  <a:srgbClr val="555555"/>
-                </a:solidFill>
-              </a:rPr>
-              <a:t>Score 62/100  ·  HOLD</a:t>
-            </a:r>
-          </a:p>
-        </p:txBody>
-      </p:sp>
-      <p:sp>
-        <p:nvSpPr>
-          <p:cNvPr id="34" name="Rectangle 33"/>
-          <p:cNvSpPr/>
-          <p:nvPr/>
-        </p:nvSpPr>
-        <p:spPr>
-          <a:xfrm>
-            <a:off x="5940000" y="2830950"/>
-            <a:ext cx="180000" cy="108000"/>
-          </a:xfrm>
-          <a:prstGeom prst="rect">
-            <a:avLst/>
-          </a:prstGeom>
-          <a:solidFill>
-            <a:srgbClr val="6B3A1B"/>
-          </a:solidFill>
-          <a:ln>
-            <a:noFill/>
-          </a:ln>
-        </p:spPr>
-        <p:style>
-          <a:lnRef idx="1">
-            <a:schemeClr val="accent1"/>
-          </a:lnRef>
-          <a:fillRef idx="3">
-            <a:schemeClr val="accent1"/>
-          </a:fillRef>
-          <a:effectRef idx="2">
-            <a:schemeClr val="accent1"/>
-          </a:effectRef>
-          <a:fontRef idx="minor">
-            <a:schemeClr val="lt1"/>
-          </a:fontRef>
-        </p:style>
-        <p:txBody>
-          <a:bodyPr rtlCol="0" anchor="ctr"/>
-          <a:lstStyle/>
-          <a:p>
-            <a:pPr algn="ctr"/>
-          </a:p>
-        </p:txBody>
-      </p:sp>
-      <p:sp>
-        <p:nvSpPr>
-          <p:cNvPr id="35" name="TextBox 34"/>
-          <p:cNvSpPr txBox="1"/>
-          <p:nvPr/>
-        </p:nvSpPr>
-        <p:spPr>
-          <a:xfrm>
-            <a:off x="6192000" y="2787750"/>
-            <a:ext cx="2556000" cy="216000"/>
-          </a:xfrm>
-          <a:prstGeom prst="rect">
-            <a:avLst/>
-          </a:prstGeom>
-          <a:noFill/>
-        </p:spPr>
-        <p:txBody>
-          <a:bodyPr wrap="square">
-            <a:spAutoFit/>
-          </a:bodyPr>
-          <a:lstStyle/>
-          <a:p>
-            <a:pPr algn="l"/>
-            <a:r>
-              <a:rPr sz="900" b="1" i="0">
-                <a:solidFill>
-                  <a:srgbClr val="1B3A6B"/>
-                </a:solidFill>
-              </a:rPr>
-              <a:t>VLO  —  Valero Energy Corporation</a:t>
-            </a:r>
-          </a:p>
-        </p:txBody>
-      </p:sp>
-      <p:sp>
-        <p:nvSpPr>
-          <p:cNvPr id="36" name="TextBox 35"/>
-          <p:cNvSpPr txBox="1"/>
-          <p:nvPr/>
-        </p:nvSpPr>
-        <p:spPr>
-          <a:xfrm>
-            <a:off x="6192000" y="3010950"/>
-            <a:ext cx="2556000" cy="180000"/>
-          </a:xfrm>
-          <a:prstGeom prst="rect">
-            <a:avLst/>
-          </a:prstGeom>
-          <a:noFill/>
-        </p:spPr>
-        <p:txBody>
-          <a:bodyPr wrap="square">
-            <a:spAutoFit/>
-          </a:bodyPr>
-          <a:lstStyle/>
-          <a:p>
-            <a:pPr algn="l"/>
-            <a:r>
-              <a:rPr sz="800" b="0" i="0">
-                <a:solidFill>
-                  <a:srgbClr val="555555"/>
-                </a:solidFill>
-              </a:rPr>
-              <a:t>Score 54/100  ·  HOLD</a:t>
-            </a:r>
-          </a:p>
-        </p:txBody>
-      </p:sp>
-      <p:sp>
-        <p:nvSpPr>
-          <p:cNvPr id="37" name="Rectangle 36"/>
-          <p:cNvSpPr/>
-          <p:nvPr/>
-        </p:nvSpPr>
-        <p:spPr>
-          <a:xfrm>
-            <a:off x="5940000" y="3161699"/>
-            <a:ext cx="180000" cy="108000"/>
-          </a:xfrm>
-          <a:prstGeom prst="rect">
-            <a:avLst/>
-          </a:prstGeom>
-          <a:solidFill>
-            <a:srgbClr val="3A6B1B"/>
-          </a:solidFill>
-          <a:ln>
-            <a:noFill/>
-          </a:ln>
-        </p:spPr>
-        <p:style>
-          <a:lnRef idx="1">
-            <a:schemeClr val="accent1"/>
-          </a:lnRef>
-          <a:fillRef idx="3">
-            <a:schemeClr val="accent1"/>
-          </a:fillRef>
-          <a:effectRef idx="2">
-            <a:schemeClr val="accent1"/>
-          </a:effectRef>
-          <a:fontRef idx="minor">
-            <a:schemeClr val="lt1"/>
-          </a:fontRef>
-        </p:style>
-        <p:txBody>
-          <a:bodyPr rtlCol="0" anchor="ctr"/>
-          <a:lstStyle/>
-          <a:p>
-            <a:pPr algn="ctr"/>
-          </a:p>
-        </p:txBody>
-      </p:sp>
-      <p:sp>
-        <p:nvSpPr>
-          <p:cNvPr id="38" name="TextBox 37"/>
-          <p:cNvSpPr txBox="1"/>
-          <p:nvPr/>
-        </p:nvSpPr>
-        <p:spPr>
-          <a:xfrm>
-            <a:off x="6192000" y="3118500"/>
-            <a:ext cx="2556000" cy="216000"/>
-          </a:xfrm>
-          <a:prstGeom prst="rect">
-            <a:avLst/>
-          </a:prstGeom>
-          <a:noFill/>
-        </p:spPr>
-        <p:txBody>
-          <a:bodyPr wrap="square">
-            <a:spAutoFit/>
-          </a:bodyPr>
-          <a:lstStyle/>
-          <a:p>
-            <a:pPr algn="l"/>
-            <a:r>
-              <a:rPr sz="900" b="1" i="0">
-                <a:solidFill>
-                  <a:srgbClr val="1B3A6B"/>
-                </a:solidFill>
-              </a:rPr>
-              <a:t>PSX  —  Phillips 66</a:t>
-            </a:r>
-          </a:p>
-        </p:txBody>
-      </p:sp>
-      <p:sp>
-        <p:nvSpPr>
-          <p:cNvPr id="39" name="TextBox 38"/>
-          <p:cNvSpPr txBox="1"/>
-          <p:nvPr/>
-        </p:nvSpPr>
-        <p:spPr>
-          <a:xfrm>
-            <a:off x="6192000" y="3341699"/>
-            <a:ext cx="2556000" cy="180000"/>
-          </a:xfrm>
-          <a:prstGeom prst="rect">
-            <a:avLst/>
-          </a:prstGeom>
-          <a:noFill/>
-        </p:spPr>
-        <p:txBody>
-          <a:bodyPr wrap="square">
-            <a:spAutoFit/>
-          </a:bodyPr>
-          <a:lstStyle/>
-          <a:p>
-            <a:pPr algn="l"/>
-            <a:r>
-              <a:rPr sz="800" b="0" i="0">
-                <a:solidFill>
-                  <a:srgbClr val="555555"/>
-                </a:solidFill>
-              </a:rPr>
-              <a:t>Score 60/100  ·  HOLD</a:t>
-            </a:r>
-          </a:p>
-        </p:txBody>
-      </p:sp>
-      <p:sp>
-        <p:nvSpPr>
-          <p:cNvPr id="40" name="Rectangle 39"/>
-          <p:cNvSpPr/>
-          <p:nvPr/>
-        </p:nvSpPr>
-        <p:spPr>
-          <a:xfrm>
-            <a:off x="5940000" y="3492449"/>
-            <a:ext cx="180000" cy="108000"/>
-          </a:xfrm>
-          <a:prstGeom prst="rect">
-            <a:avLst/>
-          </a:prstGeom>
-          <a:solidFill>
-            <a:srgbClr val="6B1B3A"/>
-          </a:solidFill>
-          <a:ln>
-            <a:noFill/>
-          </a:ln>
-        </p:spPr>
-        <p:style>
-          <a:lnRef idx="1">
-            <a:schemeClr val="accent1"/>
-          </a:lnRef>
-          <a:fillRef idx="3">
-            <a:schemeClr val="accent1"/>
-          </a:fillRef>
-          <a:effectRef idx="2">
-            <a:schemeClr val="accent1"/>
-          </a:effectRef>
-          <a:fontRef idx="minor">
-            <a:schemeClr val="lt1"/>
-          </a:fontRef>
-        </p:style>
-        <p:txBody>
-          <a:bodyPr rtlCol="0" anchor="ctr"/>
-          <a:lstStyle/>
-          <a:p>
-            <a:pPr algn="ctr"/>
-          </a:p>
-        </p:txBody>
-      </p:sp>
-      <p:sp>
-        <p:nvSpPr>
-          <p:cNvPr id="41" name="TextBox 40"/>
-          <p:cNvSpPr txBox="1"/>
-          <p:nvPr/>
-        </p:nvSpPr>
-        <p:spPr>
-          <a:xfrm>
-            <a:off x="6192000" y="3449249"/>
-            <a:ext cx="2556000" cy="216000"/>
-          </a:xfrm>
-          <a:prstGeom prst="rect">
-            <a:avLst/>
-          </a:prstGeom>
-          <a:noFill/>
-        </p:spPr>
-        <p:txBody>
-          <a:bodyPr wrap="square">
-            <a:spAutoFit/>
-          </a:bodyPr>
-          <a:lstStyle/>
-          <a:p>
-            <a:pPr algn="l"/>
-            <a:r>
-              <a:rPr sz="900" b="1" i="0">
-                <a:solidFill>
-                  <a:srgbClr val="1B3A6B"/>
-                </a:solidFill>
-              </a:rPr>
-              <a:t>MPC  —  Marathon Petroleum Corporation</a:t>
-            </a:r>
-          </a:p>
-        </p:txBody>
-      </p:sp>
-      <p:sp>
-        <p:nvSpPr>
-          <p:cNvPr id="42" name="TextBox 41"/>
-          <p:cNvSpPr txBox="1"/>
-          <p:nvPr/>
-        </p:nvSpPr>
-        <p:spPr>
-          <a:xfrm>
-            <a:off x="6192000" y="3672449"/>
-            <a:ext cx="2556000" cy="180000"/>
-          </a:xfrm>
-          <a:prstGeom prst="rect">
-            <a:avLst/>
-          </a:prstGeom>
-          <a:noFill/>
-        </p:spPr>
-        <p:txBody>
-          <a:bodyPr wrap="square">
-            <a:spAutoFit/>
-          </a:bodyPr>
-          <a:lstStyle/>
-          <a:p>
-            <a:pPr algn="l"/>
-            <a:r>
-              <a:rPr sz="800" b="0" i="0">
-                <a:solidFill>
-                  <a:srgbClr val="555555"/>
-                </a:solidFill>
-              </a:rPr>
-              <a:t>Score 59/100  ·  HOLD</a:t>
-            </a:r>
-          </a:p>
-        </p:txBody>
-      </p:sp>
-      <p:sp>
-        <p:nvSpPr>
-          <p:cNvPr id="43" name="Rectangle 42"/>
-          <p:cNvSpPr/>
-          <p:nvPr/>
-        </p:nvSpPr>
-        <p:spPr>
-          <a:xfrm>
-            <a:off x="5903999" y="3780000"/>
-            <a:ext cx="2916000" cy="18000"/>
-          </a:xfrm>
-          <a:prstGeom prst="rect">
-            <a:avLst/>
-          </a:prstGeom>
-          <a:solidFill>
-            <a:srgbClr val="AAAAAA"/>
-          </a:solidFill>
-          <a:ln>
-            <a:noFill/>
-          </a:ln>
-        </p:spPr>
-        <p:style>
-          <a:lnRef idx="1">
-            <a:schemeClr val="accent1"/>
-          </a:lnRef>
-          <a:fillRef idx="3">
-            <a:schemeClr val="accent1"/>
-          </a:fillRef>
-          <a:effectRef idx="2">
-            <a:schemeClr val="accent1"/>
-          </a:effectRef>
-          <a:fontRef idx="minor">
-            <a:schemeClr val="lt1"/>
-          </a:fontRef>
-        </p:style>
-        <p:txBody>
-          <a:bodyPr rtlCol="0" anchor="ctr"/>
-          <a:lstStyle/>
-          <a:p>
-            <a:pPr algn="ctr"/>
-          </a:p>
-        </p:txBody>
-      </p:sp>
-      <p:sp>
-        <p:nvSpPr>
-          <p:cNvPr id="44" name="TextBox 43"/>
-          <p:cNvSpPr txBox="1"/>
-          <p:nvPr/>
-        </p:nvSpPr>
-        <p:spPr>
-          <a:xfrm>
-            <a:off x="5976000" y="3816000"/>
-            <a:ext cx="2808000" cy="180000"/>
-          </a:xfrm>
-          <a:prstGeom prst="rect">
-            <a:avLst/>
-          </a:prstGeom>
-          <a:noFill/>
-        </p:spPr>
-        <p:txBody>
-          <a:bodyPr wrap="square">
-            <a:spAutoFit/>
-          </a:bodyPr>
-          <a:lstStyle/>
-          <a:p>
-            <a:pPr algn="l"/>
-            <a:r>
-              <a:rPr sz="750" b="1" i="0">
-                <a:solidFill>
-                  <a:srgbClr val="1B3A6B"/>
-                </a:solidFill>
-              </a:rPr>
-              <a:t>LECTURE ANALYTIQUE</a:t>
-            </a:r>
-          </a:p>
-        </p:txBody>
-      </p:sp>
-      <p:sp>
-        <p:nvSpPr>
-          <p:cNvPr id="45" name="TextBox 44"/>
-          <p:cNvSpPr txBox="1"/>
-          <p:nvPr/>
-        </p:nvSpPr>
-        <p:spPr>
-          <a:xfrm>
-            <a:off x="5976000" y="4014000"/>
-            <a:ext cx="2808000" cy="612000"/>
-          </a:xfrm>
-          <a:prstGeom prst="rect">
-            <a:avLst/>
-          </a:prstGeom>
-          <a:noFill/>
-        </p:spPr>
-        <p:txBody>
-          <a:bodyPr wrap="square">
-            <a:spAutoFit/>
-          </a:bodyPr>
-          <a:lstStyle/>
-          <a:p>
-            <a:pPr algn="l"/>
-            <a:r>
-              <a:rPr sz="700" b="0" i="0">
-                <a:solidFill>
-                  <a:srgbClr val="555555"/>
-                </a:solidFill>
-              </a:rPr>
-              <a:t>Sur 52 semaines, VLO affiche la meilleure performance (+82%) tandis que EOG est en retard (+8%). La dispersion des trajectoires illustre la bifurcation sectorielle. Le momentum 52W est integre dans le score FinSight comme signal de confirmation.</a:t>
-            </a:r>
-          </a:p>
-        </p:txBody>
-      </p:sp>
-      <p:sp>
-        <p:nvSpPr>
-          <p:cNvPr id="46" name="Rectangle 45"/>
+              <a:t>Le momentum 52W est integre dans le score FinSight comme signal de confirmation de la these d'investissement.</a:t>
+            </a:r>
+          </a:p>
+        </p:txBody>
+      </p:sp>
+      <p:sp>
+        <p:nvSpPr>
+          <p:cNvPr id="28" name="Rectangle 27"/>
           <p:cNvSpPr/>
           <p:nvPr/>
         </p:nvSpPr>
@@ -23053,7 +22360,7 @@
       </p:sp>
       <p:sp>
         <p:nvSpPr>
-          <p:cNvPr id="47" name="TextBox 46"/>
+          <p:cNvPr id="29" name="TextBox 28"/>
           <p:cNvSpPr txBox="1"/>
           <p:nvPr/>
         </p:nvSpPr>

</xml_diff>